<commit_message>
Finished the basic CSS styling. Need to finish a few little things to finish layout of the site
</commit_message>
<xml_diff>
--- a/Web Dev Assignment 2 & 3.pptx
+++ b/Web Dev Assignment 2 & 3.pptx
@@ -120,6 +120,14 @@
     </p:ext>
   </p:extLst>
 </p:presentation>
+</file>
+
+<file path=ppt/revisionInfo.xml><?xml version="1.0" encoding="utf-8"?>
+<p1510:revInfo xmlns:a="http://schemas.openxmlformats.org/drawingml/2006/main" xmlns:r="http://schemas.openxmlformats.org/officeDocument/2006/relationships" xmlns:p1510="http://schemas.microsoft.com/office/powerpoint/2015/10/main">
+  <p1510:revLst>
+    <p1510:client id="{94491AF3-4F8C-4C8F-A431-D3DB264040D9}" v="43" dt="2026-04-24T10:45:30.878"/>
+  </p1510:revLst>
+</p1510:revInfo>
 </file>
 
 <file path=ppt/changesInfos/changesInfo1.xml><?xml version="1.0" encoding="utf-8"?>
@@ -1388,7 +1396,7 @@
           <a:bodyPr/>
           <a:lstStyle/>
           <a:p>
-            <a:endParaRPr lang="en-GB"/>
+            <a:endParaRPr lang="en-GB" dirty="0"/>
           </a:p>
         </p:txBody>
       </p:sp>
@@ -4685,7 +4693,7 @@
           <a:lstStyle/>
           <a:p>
             <a:r>
-              <a:rPr lang="en-GB" u="sng"/>
+              <a:rPr lang="en-GB" u="sng" dirty="0"/>
               <a:t>Web Dev Assignment 2 &amp; 3</a:t>
             </a:r>
           </a:p>
@@ -4766,7 +4774,7 @@
           <a:lstStyle/>
           <a:p>
             <a:pPr algn="ctr"/>
-            <a:endParaRPr lang="en-GB"/>
+            <a:endParaRPr lang="en-GB" dirty="0"/>
           </a:p>
         </p:txBody>
       </p:sp>
@@ -4799,7 +4807,7 @@
           <a:lstStyle/>
           <a:p>
             <a:r>
-              <a:rPr lang="en-GB"/>
+              <a:rPr lang="en-GB" dirty="0"/>
               <a:t>Index</a:t>
             </a:r>
           </a:p>
@@ -4850,7 +4858,7 @@
           <a:lstStyle/>
           <a:p>
             <a:pPr algn="ctr"/>
-            <a:endParaRPr lang="en-GB"/>
+            <a:endParaRPr lang="en-GB" dirty="0"/>
           </a:p>
         </p:txBody>
       </p:sp>
@@ -4899,7 +4907,7 @@
           <a:lstStyle/>
           <a:p>
             <a:pPr algn="ctr"/>
-            <a:endParaRPr lang="en-GB"/>
+            <a:endParaRPr lang="en-GB" dirty="0"/>
           </a:p>
         </p:txBody>
       </p:sp>
@@ -4948,7 +4956,7 @@
           <a:lstStyle/>
           <a:p>
             <a:pPr algn="ctr"/>
-            <a:endParaRPr lang="en-GB"/>
+            <a:endParaRPr lang="en-GB" dirty="0"/>
           </a:p>
         </p:txBody>
       </p:sp>
@@ -4997,7 +5005,7 @@
           <a:lstStyle/>
           <a:p>
             <a:pPr algn="ctr"/>
-            <a:endParaRPr lang="en-GB"/>
+            <a:endParaRPr lang="en-GB" dirty="0"/>
           </a:p>
         </p:txBody>
       </p:sp>
@@ -5315,7 +5323,7 @@
           <a:lstStyle/>
           <a:p>
             <a:r>
-              <a:rPr lang="en-GB"/>
+              <a:rPr lang="en-GB" dirty="0"/>
               <a:t>Courses</a:t>
             </a:r>
           </a:p>
@@ -5350,7 +5358,7 @@
           <a:lstStyle/>
           <a:p>
             <a:r>
-              <a:rPr lang="en-GB"/>
+              <a:rPr lang="en-GB" dirty="0"/>
               <a:t>About</a:t>
             </a:r>
           </a:p>
@@ -5385,7 +5393,7 @@
           <a:lstStyle/>
           <a:p>
             <a:r>
-              <a:rPr lang="en-GB"/>
+              <a:rPr lang="en-GB" dirty="0"/>
               <a:t>Application</a:t>
             </a:r>
           </a:p>
@@ -5420,7 +5428,7 @@
           <a:lstStyle/>
           <a:p>
             <a:r>
-              <a:rPr lang="en-GB"/>
+              <a:rPr lang="en-GB" dirty="0"/>
               <a:t>Contact</a:t>
             </a:r>
           </a:p>
@@ -5485,7 +5493,7 @@
           <a:lstStyle/>
           <a:p>
             <a:r>
-              <a:rPr lang="en-GB" sz="2800">
+              <a:rPr lang="en-GB" sz="2800" dirty="0">
                 <a:latin typeface="+mj-lt"/>
                 <a:cs typeface="Arial" panose="020B0604020202020204" pitchFamily="34" charset="0"/>
               </a:rPr>
@@ -5523,7 +5531,7 @@
           <a:lstStyle/>
           <a:p>
             <a:r>
-              <a:rPr lang="en-GB">
+              <a:rPr lang="en-GB" dirty="0">
                 <a:solidFill>
                   <a:schemeClr val="accent2"/>
                 </a:solidFill>
@@ -5562,7 +5570,7 @@
           <a:lstStyle/>
           <a:p>
             <a:r>
-              <a:rPr lang="en-GB">
+              <a:rPr lang="en-GB" dirty="0">
                 <a:solidFill>
                   <a:schemeClr val="accent2"/>
                 </a:solidFill>
@@ -5601,7 +5609,7 @@
           <a:lstStyle/>
           <a:p>
             <a:r>
-              <a:rPr lang="en-GB">
+              <a:rPr lang="en-GB" dirty="0">
                 <a:solidFill>
                   <a:schemeClr val="accent2"/>
                 </a:solidFill>
@@ -5640,7 +5648,7 @@
           <a:lstStyle/>
           <a:p>
             <a:r>
-              <a:rPr lang="en-GB">
+              <a:rPr lang="en-GB" dirty="0">
                 <a:solidFill>
                   <a:schemeClr val="accent2"/>
                 </a:solidFill>
@@ -5679,7 +5687,7 @@
           <a:lstStyle/>
           <a:p>
             <a:r>
-              <a:rPr lang="en-GB">
+              <a:rPr lang="en-GB" dirty="0">
                 <a:solidFill>
                   <a:schemeClr val="accent2"/>
                 </a:solidFill>
@@ -5718,7 +5726,7 @@
           <a:lstStyle/>
           <a:p>
             <a:r>
-              <a:rPr lang="en-GB">
+              <a:rPr lang="en-GB" dirty="0">
                 <a:solidFill>
                   <a:srgbClr val="FF0000"/>
                 </a:solidFill>
@@ -5905,7 +5913,11 @@
           <a:p>
             <a:r>
               <a:rPr lang="en-GB"/>
-              <a:t>Our Developers:</a:t>
+              <a:t>Our </a:t>
+            </a:r>
+            <a:r>
+              <a:rPr lang="en-GB" dirty="0"/>
+              <a:t>Developers:</a:t>
             </a:r>
           </a:p>
         </p:txBody>
@@ -5939,7 +5951,7 @@
           <a:lstStyle/>
           <a:p>
             <a:r>
-              <a:rPr lang="en-GB"/>
+              <a:rPr lang="en-GB" dirty="0"/>
               <a:t>Dev  1</a:t>
             </a:r>
           </a:p>
@@ -5974,7 +5986,7 @@
           <a:lstStyle/>
           <a:p>
             <a:r>
-              <a:rPr lang="en-GB"/>
+              <a:rPr lang="en-GB" dirty="0"/>
               <a:t>Dev  2</a:t>
             </a:r>
           </a:p>
@@ -6009,7 +6021,7 @@
           <a:lstStyle/>
           <a:p>
             <a:r>
-              <a:rPr lang="en-GB"/>
+              <a:rPr lang="en-GB" dirty="0"/>
               <a:t>Dev 3</a:t>
             </a:r>
           </a:p>
@@ -6368,7 +6380,7 @@
           <a:lstStyle/>
           <a:p>
             <a:r>
-              <a:rPr lang="en-GB"/>
+              <a:rPr lang="en-GB" dirty="0"/>
               <a:t>Home</a:t>
             </a:r>
           </a:p>
@@ -6403,7 +6415,7 @@
           <a:lstStyle/>
           <a:p>
             <a:r>
-              <a:rPr lang="en-GB"/>
+              <a:rPr lang="en-GB" dirty="0"/>
               <a:t>Courses</a:t>
             </a:r>
           </a:p>
@@ -6438,7 +6450,7 @@
           <a:lstStyle/>
           <a:p>
             <a:r>
-              <a:rPr lang="en-GB"/>
+              <a:rPr lang="en-GB" dirty="0"/>
               <a:t>About</a:t>
             </a:r>
           </a:p>
@@ -6473,7 +6485,7 @@
           <a:lstStyle/>
           <a:p>
             <a:r>
-              <a:rPr lang="en-GB"/>
+              <a:rPr lang="en-GB" dirty="0"/>
               <a:t>Application</a:t>
             </a:r>
           </a:p>
@@ -6508,7 +6520,7 @@
           <a:lstStyle/>
           <a:p>
             <a:r>
-              <a:rPr lang="en-GB"/>
+              <a:rPr lang="en-GB" dirty="0"/>
               <a:t>Contact</a:t>
             </a:r>
           </a:p>
@@ -6543,7 +6555,7 @@
           <a:lstStyle/>
           <a:p>
             <a:r>
-              <a:rPr lang="en-GB">
+              <a:rPr lang="en-GB" dirty="0">
                 <a:solidFill>
                   <a:srgbClr val="FF0000"/>
                 </a:solidFill>
@@ -6762,7 +6774,7 @@
           <a:lstStyle/>
           <a:p>
             <a:r>
-              <a:rPr lang="en-GB"/>
+              <a:rPr lang="en-GB" dirty="0"/>
               <a:t>Course Title</a:t>
             </a:r>
           </a:p>
@@ -6797,7 +6809,7 @@
           <a:lstStyle/>
           <a:p>
             <a:r>
-              <a:rPr lang="en-GB"/>
+              <a:rPr lang="en-GB" dirty="0"/>
               <a:t>Duration</a:t>
             </a:r>
           </a:p>
@@ -6832,7 +6844,7 @@
           <a:lstStyle/>
           <a:p>
             <a:r>
-              <a:rPr lang="en-GB"/>
+              <a:rPr lang="en-GB" dirty="0"/>
               <a:t>Level</a:t>
             </a:r>
           </a:p>
@@ -7096,7 +7108,7 @@
           <a:lstStyle/>
           <a:p>
             <a:r>
-              <a:rPr lang="en-GB"/>
+              <a:rPr lang="en-GB" dirty="0"/>
               <a:t>Course Title</a:t>
             </a:r>
           </a:p>
@@ -7131,7 +7143,7 @@
           <a:lstStyle/>
           <a:p>
             <a:r>
-              <a:rPr lang="en-GB"/>
+              <a:rPr lang="en-GB" dirty="0"/>
               <a:t>Duration</a:t>
             </a:r>
           </a:p>
@@ -7166,7 +7178,7 @@
           <a:lstStyle/>
           <a:p>
             <a:r>
-              <a:rPr lang="en-GB"/>
+              <a:rPr lang="en-GB" dirty="0"/>
               <a:t>Level</a:t>
             </a:r>
           </a:p>
@@ -7430,7 +7442,7 @@
           <a:lstStyle/>
           <a:p>
             <a:r>
-              <a:rPr lang="en-GB"/>
+              <a:rPr lang="en-GB" dirty="0"/>
               <a:t>Course Title</a:t>
             </a:r>
           </a:p>
@@ -7465,7 +7477,7 @@
           <a:lstStyle/>
           <a:p>
             <a:r>
-              <a:rPr lang="en-GB"/>
+              <a:rPr lang="en-GB" dirty="0"/>
               <a:t>Duration</a:t>
             </a:r>
           </a:p>
@@ -7500,7 +7512,7 @@
           <a:lstStyle/>
           <a:p>
             <a:r>
-              <a:rPr lang="en-GB"/>
+              <a:rPr lang="en-GB" dirty="0"/>
               <a:t>Level</a:t>
             </a:r>
           </a:p>
@@ -7764,7 +7776,7 @@
           <a:lstStyle/>
           <a:p>
             <a:r>
-              <a:rPr lang="en-GB"/>
+              <a:rPr lang="en-GB" dirty="0"/>
               <a:t>Course Title</a:t>
             </a:r>
           </a:p>
@@ -7799,7 +7811,7 @@
           <a:lstStyle/>
           <a:p>
             <a:r>
-              <a:rPr lang="en-GB"/>
+              <a:rPr lang="en-GB" dirty="0"/>
               <a:t>Duration</a:t>
             </a:r>
           </a:p>
@@ -7834,7 +7846,7 @@
           <a:lstStyle/>
           <a:p>
             <a:r>
-              <a:rPr lang="en-GB"/>
+              <a:rPr lang="en-GB" dirty="0"/>
               <a:t>Level</a:t>
             </a:r>
           </a:p>
@@ -8098,7 +8110,7 @@
           <a:lstStyle/>
           <a:p>
             <a:r>
-              <a:rPr lang="en-GB"/>
+              <a:rPr lang="en-GB" dirty="0"/>
               <a:t>Course Title</a:t>
             </a:r>
           </a:p>
@@ -8133,7 +8145,7 @@
           <a:lstStyle/>
           <a:p>
             <a:r>
-              <a:rPr lang="en-GB"/>
+              <a:rPr lang="en-GB" dirty="0"/>
               <a:t>Duration</a:t>
             </a:r>
           </a:p>
@@ -8168,7 +8180,7 @@
           <a:lstStyle/>
           <a:p>
             <a:r>
-              <a:rPr lang="en-GB"/>
+              <a:rPr lang="en-GB" dirty="0"/>
               <a:t>Level</a:t>
             </a:r>
           </a:p>
@@ -8282,7 +8294,7 @@
           <a:lstStyle/>
           <a:p>
             <a:r>
-              <a:rPr lang="en-GB">
+              <a:rPr lang="en-GB" dirty="0">
                 <a:solidFill>
                   <a:srgbClr val="FF0000"/>
                 </a:solidFill>
@@ -8370,12 +8382,12 @@
           <a:lstStyle/>
           <a:p>
             <a:r>
-              <a:rPr lang="en-GB"/>
+              <a:rPr lang="en-GB" dirty="0"/>
               <a:t>Headline</a:t>
             </a:r>
           </a:p>
           <a:p>
-            <a:endParaRPr lang="en-GB"/>
+            <a:endParaRPr lang="en-GB" dirty="0"/>
           </a:p>
         </p:txBody>
       </p:sp>
@@ -8408,7 +8420,7 @@
           <a:lstStyle/>
           <a:p>
             <a:r>
-              <a:rPr lang="en-GB"/>
+              <a:rPr lang="en-GB" dirty="0"/>
               <a:t>Sub Text</a:t>
             </a:r>
           </a:p>
@@ -8594,7 +8606,7 @@
           <a:lstStyle/>
           <a:p>
             <a:r>
-              <a:rPr lang="en-GB"/>
+              <a:rPr lang="en-GB" dirty="0"/>
               <a:t>Train</a:t>
             </a:r>
           </a:p>
@@ -8629,7 +8641,7 @@
           <a:lstStyle/>
           <a:p>
             <a:r>
-              <a:rPr lang="en-GB"/>
+              <a:rPr lang="en-GB" dirty="0"/>
               <a:t>Assess</a:t>
             </a:r>
           </a:p>
@@ -8664,7 +8676,7 @@
           <a:lstStyle/>
           <a:p>
             <a:r>
-              <a:rPr lang="en-GB"/>
+              <a:rPr lang="en-GB" dirty="0"/>
               <a:t>Connect</a:t>
             </a:r>
           </a:p>
@@ -8748,7 +8760,7 @@
           <a:lstStyle/>
           <a:p>
             <a:r>
-              <a:rPr lang="en-GB"/>
+              <a:rPr lang="en-GB" dirty="0"/>
               <a:t>Our Mission</a:t>
             </a:r>
           </a:p>
@@ -8832,7 +8844,7 @@
           <a:lstStyle/>
           <a:p>
             <a:r>
-              <a:rPr lang="en-GB"/>
+              <a:rPr lang="en-GB" dirty="0"/>
               <a:t>Stats</a:t>
             </a:r>
           </a:p>
@@ -9112,7 +9124,7 @@
           <a:lstStyle/>
           <a:p>
             <a:r>
-              <a:rPr lang="en-GB"/>
+              <a:rPr lang="en-GB" dirty="0"/>
               <a:t>Home</a:t>
             </a:r>
           </a:p>
@@ -9147,7 +9159,7 @@
           <a:lstStyle/>
           <a:p>
             <a:r>
-              <a:rPr lang="en-GB"/>
+              <a:rPr lang="en-GB" dirty="0"/>
               <a:t>Courses</a:t>
             </a:r>
           </a:p>
@@ -9182,7 +9194,7 @@
           <a:lstStyle/>
           <a:p>
             <a:r>
-              <a:rPr lang="en-GB"/>
+              <a:rPr lang="en-GB" dirty="0"/>
               <a:t>About</a:t>
             </a:r>
           </a:p>
@@ -9217,7 +9229,7 @@
           <a:lstStyle/>
           <a:p>
             <a:r>
-              <a:rPr lang="en-GB"/>
+              <a:rPr lang="en-GB" dirty="0"/>
               <a:t>Application</a:t>
             </a:r>
           </a:p>
@@ -9252,7 +9264,7 @@
           <a:lstStyle/>
           <a:p>
             <a:r>
-              <a:rPr lang="en-GB"/>
+              <a:rPr lang="en-GB" dirty="0"/>
               <a:t>Contact</a:t>
             </a:r>
           </a:p>
@@ -9366,7 +9378,7 @@
           <a:lstStyle/>
           <a:p>
             <a:r>
-              <a:rPr lang="en-GB">
+              <a:rPr lang="en-GB" dirty="0">
                 <a:solidFill>
                   <a:srgbClr val="FF0000"/>
                 </a:solidFill>
@@ -9515,7 +9527,7 @@
           <a:lstStyle/>
           <a:p>
             <a:r>
-              <a:rPr lang="en-GB"/>
+              <a:rPr lang="en-GB" dirty="0"/>
               <a:t>Progress Bar</a:t>
             </a:r>
           </a:p>
@@ -9599,19 +9611,19 @@
           <a:lstStyle/>
           <a:p>
             <a:r>
-              <a:rPr lang="en-GB"/>
+              <a:rPr lang="en-GB" dirty="0"/>
               <a:t>Full Name   [______]</a:t>
             </a:r>
           </a:p>
           <a:p>
             <a:r>
-              <a:rPr lang="en-GB"/>
+              <a:rPr lang="en-GB" dirty="0"/>
               <a:t>Email             [______]</a:t>
             </a:r>
           </a:p>
           <a:p>
             <a:r>
-              <a:rPr lang="en-GB"/>
+              <a:rPr lang="en-GB" dirty="0"/>
               <a:t>Location      [______]</a:t>
             </a:r>
           </a:p>
@@ -9646,7 +9658,7 @@
           <a:lstStyle/>
           <a:p>
             <a:r>
-              <a:rPr lang="en-GB"/>
+              <a:rPr lang="en-GB" dirty="0"/>
               <a:t>Next</a:t>
             </a:r>
           </a:p>
@@ -9817,7 +9829,7 @@
           <a:lstStyle/>
           <a:p>
             <a:r>
-              <a:rPr lang="en-GB"/>
+              <a:rPr lang="en-GB" dirty="0"/>
               <a:t>Coding Experience</a:t>
             </a:r>
           </a:p>
@@ -9999,7 +10011,7 @@
           <a:lstStyle/>
           <a:p>
             <a:r>
-              <a:rPr lang="en-GB"/>
+              <a:rPr lang="en-GB" dirty="0"/>
               <a:t>Next</a:t>
             </a:r>
           </a:p>
@@ -10083,7 +10095,7 @@
           <a:lstStyle/>
           <a:p>
             <a:r>
-              <a:rPr lang="en-GB"/>
+              <a:rPr lang="en-GB" dirty="0"/>
               <a:t>Application Submitted!</a:t>
             </a:r>
           </a:p>
@@ -10118,12 +10130,12 @@
           <a:lstStyle/>
           <a:p>
             <a:r>
-              <a:rPr lang="en-GB"/>
+              <a:rPr lang="en-GB" dirty="0"/>
               <a:t>Next Steps:</a:t>
             </a:r>
           </a:p>
           <a:p>
-            <a:endParaRPr lang="en-GB"/>
+            <a:endParaRPr lang="en-GB" dirty="0"/>
           </a:p>
         </p:txBody>
       </p:sp>
@@ -10156,7 +10168,7 @@
           <a:lstStyle/>
           <a:p>
             <a:r>
-              <a:rPr lang="en-GB"/>
+              <a:rPr lang="en-GB" dirty="0"/>
               <a:t>Home</a:t>
             </a:r>
           </a:p>
@@ -10436,7 +10448,7 @@
           <a:lstStyle/>
           <a:p>
             <a:r>
-              <a:rPr lang="en-GB"/>
+              <a:rPr lang="en-GB" dirty="0"/>
               <a:t>Home</a:t>
             </a:r>
           </a:p>
@@ -10471,7 +10483,7 @@
           <a:lstStyle/>
           <a:p>
             <a:r>
-              <a:rPr lang="en-GB"/>
+              <a:rPr lang="en-GB" dirty="0"/>
               <a:t>Courses</a:t>
             </a:r>
           </a:p>
@@ -10506,7 +10518,7 @@
           <a:lstStyle/>
           <a:p>
             <a:r>
-              <a:rPr lang="en-GB"/>
+              <a:rPr lang="en-GB" dirty="0"/>
               <a:t>About</a:t>
             </a:r>
           </a:p>
@@ -10541,7 +10553,7 @@
           <a:lstStyle/>
           <a:p>
             <a:r>
-              <a:rPr lang="en-GB"/>
+              <a:rPr lang="en-GB" dirty="0"/>
               <a:t>Application</a:t>
             </a:r>
           </a:p>
@@ -10576,7 +10588,7 @@
           <a:lstStyle/>
           <a:p>
             <a:r>
-              <a:rPr lang="en-GB"/>
+              <a:rPr lang="en-GB" dirty="0"/>
               <a:t>Contact</a:t>
             </a:r>
           </a:p>
@@ -10984,7 +10996,7 @@
           <a:lstStyle/>
           <a:p>
             <a:r>
-              <a:rPr lang="en-GB"/>
+              <a:rPr lang="en-GB" dirty="0"/>
               <a:t>Home</a:t>
             </a:r>
           </a:p>
@@ -11019,7 +11031,7 @@
           <a:lstStyle/>
           <a:p>
             <a:r>
-              <a:rPr lang="en-GB"/>
+              <a:rPr lang="en-GB" dirty="0"/>
               <a:t>Courses</a:t>
             </a:r>
           </a:p>
@@ -11054,7 +11066,7 @@
           <a:lstStyle/>
           <a:p>
             <a:r>
-              <a:rPr lang="en-GB"/>
+              <a:rPr lang="en-GB" dirty="0"/>
               <a:t>About</a:t>
             </a:r>
           </a:p>
@@ -11089,7 +11101,7 @@
           <a:lstStyle/>
           <a:p>
             <a:r>
-              <a:rPr lang="en-GB"/>
+              <a:rPr lang="en-GB" dirty="0"/>
               <a:t>Application</a:t>
             </a:r>
           </a:p>
@@ -11124,7 +11136,7 @@
           <a:lstStyle/>
           <a:p>
             <a:r>
-              <a:rPr lang="en-GB"/>
+              <a:rPr lang="en-GB" dirty="0"/>
               <a:t>Contact</a:t>
             </a:r>
           </a:p>
@@ -11159,16 +11171,16 @@
           <a:lstStyle/>
           <a:p>
             <a:r>
-              <a:rPr lang="en-GB"/>
+              <a:rPr lang="en-GB" dirty="0"/>
               <a:t>Get in touch!</a:t>
             </a:r>
           </a:p>
           <a:p>
-            <a:endParaRPr lang="en-GB"/>
-          </a:p>
-          <a:p>
-            <a:r>
-              <a:rPr lang="en-GB"/>
+            <a:endParaRPr lang="en-GB" dirty="0"/>
+          </a:p>
+          <a:p>
+            <a:r>
+              <a:rPr lang="en-GB" dirty="0"/>
               <a:t>We’d love to hear from you!</a:t>
             </a:r>
           </a:p>
@@ -11203,28 +11215,28 @@
           <a:lstStyle/>
           <a:p>
             <a:r>
-              <a:rPr lang="en-GB"/>
+              <a:rPr lang="en-GB" dirty="0"/>
               <a:t>Email:</a:t>
             </a:r>
           </a:p>
           <a:p>
-            <a:endParaRPr lang="en-GB"/>
-          </a:p>
-          <a:p>
-            <a:endParaRPr lang="en-GB"/>
-          </a:p>
-          <a:p>
-            <a:r>
-              <a:rPr lang="en-GB"/>
+            <a:endParaRPr lang="en-GB" dirty="0"/>
+          </a:p>
+          <a:p>
+            <a:endParaRPr lang="en-GB" dirty="0"/>
+          </a:p>
+          <a:p>
+            <a:r>
+              <a:rPr lang="en-GB" dirty="0"/>
               <a:t>Applicants:</a:t>
             </a:r>
           </a:p>
           <a:p>
-            <a:endParaRPr lang="en-GB"/>
-          </a:p>
-          <a:p>
-            <a:r>
-              <a:rPr lang="en-GB"/>
+            <a:endParaRPr lang="en-GB" dirty="0"/>
+          </a:p>
+          <a:p>
+            <a:r>
+              <a:rPr lang="en-GB" dirty="0"/>
               <a:t>Employers:</a:t>
             </a:r>
           </a:p>
@@ -11264,7 +11276,15 @@
                   <a:srgbClr val="FF0000"/>
                 </a:solidFill>
               </a:rPr>
-              <a:t>Contact Page Wireframe</a:t>
+              <a:t>Contact </a:t>
+            </a:r>
+            <a:r>
+              <a:rPr lang="en-GB" dirty="0">
+                <a:solidFill>
+                  <a:srgbClr val="FF0000"/>
+                </a:solidFill>
+              </a:rPr>
+              <a:t>Page Wireframe</a:t>
             </a:r>
           </a:p>
         </p:txBody>
@@ -11326,7 +11346,7 @@
           <a:lstStyle/>
           <a:p>
             <a:r>
-              <a:rPr lang="en-GB"/>
+              <a:rPr lang="en-GB" dirty="0"/>
               <a:t>Typography and Colour Scheme</a:t>
             </a:r>
           </a:p>
@@ -11361,24 +11381,24 @@
           <a:lstStyle/>
           <a:p>
             <a:r>
-              <a:rPr lang="en-GB"/>
+              <a:rPr lang="en-GB" dirty="0"/>
               <a:t>I am going to use a colour scheme of two colours consisting of white and a </a:t>
             </a:r>
             <a:r>
-              <a:rPr lang="en-GB" err="1"/>
+              <a:rPr lang="en-GB" dirty="0" err="1"/>
               <a:t>brown.This</a:t>
             </a:r>
             <a:r>
-              <a:rPr lang="en-GB"/>
+              <a:rPr lang="en-GB" dirty="0"/>
               <a:t> is to make the site look professional and keep the look of a modern website. It was important that the colours I pick don’t stand out and make the site look uncomfortable to read. So, using these two colours will help a user clearly read the site and the text on screen and has a similar feel to coffee beans referencing the name of the site, hot beans</a:t>
             </a:r>
           </a:p>
           <a:p>
-            <a:endParaRPr lang="en-GB"/>
-          </a:p>
-          <a:p>
-            <a:r>
-              <a:rPr lang="en-GB"/>
+            <a:endParaRPr lang="en-GB" dirty="0"/>
+          </a:p>
+          <a:p>
+            <a:r>
+              <a:rPr lang="en-GB" dirty="0"/>
               <a:t>For fonts, I will use Playfair display as it creates a sharp modern feel to the website and the words power and keeps the serious nature of the website.</a:t>
             </a:r>
           </a:p>

</xml_diff>